<commit_message>
Publish live deployment links, pilot data policy, and polished pitch assets
</commit_message>
<xml_diff>
--- a/deliverables/remainder-pitch.pptx
+++ b/deliverables/remainder-pitch.pptx
@@ -2,19 +2,19 @@
 <file path=ppt/presentation.xml><?xml version="1.0" encoding="utf-8"?>
 <p:presentation xmlns:p="http://schemas.openxmlformats.org/presentationml/2006/main">
   <p:sldMasterIdLst>
-    <p:sldMasterId xmlns:r="http://schemas.openxmlformats.org/officeDocument/2006/relationships" id="2147483648" r:id="R228a8cbd69644eae"/>
+    <p:sldMasterId xmlns:r="http://schemas.openxmlformats.org/officeDocument/2006/relationships" id="2147483648" r:id="R6dce5656c5124ac9"/>
   </p:sldMasterIdLst>
   <p:notesMasterIdLst>
-    <p:notesMasterId xmlns:r="http://schemas.openxmlformats.org/officeDocument/2006/relationships" r:id="Rc8960e37f2464081"/>
+    <p:notesMasterId xmlns:r="http://schemas.openxmlformats.org/officeDocument/2006/relationships" r:id="R7c7731b47cef461e"/>
   </p:notesMasterIdLst>
   <p:sldIdLst>
-    <p:sldId xmlns:r="http://schemas.openxmlformats.org/officeDocument/2006/relationships" id="256" r:id="R6af06ae9f4b24e38"/>
-    <p:sldId xmlns:r="http://schemas.openxmlformats.org/officeDocument/2006/relationships" id="257" r:id="Rd05ad8da8f9a428a"/>
-    <p:sldId xmlns:r="http://schemas.openxmlformats.org/officeDocument/2006/relationships" id="258" r:id="R1a8cb2c08dae4cca"/>
-    <p:sldId xmlns:r="http://schemas.openxmlformats.org/officeDocument/2006/relationships" id="259" r:id="R281239c37c6d4180"/>
-    <p:sldId xmlns:r="http://schemas.openxmlformats.org/officeDocument/2006/relationships" id="260" r:id="R6a73c1f2aeb74204"/>
-    <p:sldId xmlns:r="http://schemas.openxmlformats.org/officeDocument/2006/relationships" id="261" r:id="R858af5b7cb7949da"/>
-    <p:sldId xmlns:r="http://schemas.openxmlformats.org/officeDocument/2006/relationships" id="262" r:id="Ra18cbd30ee5643cb"/>
+    <p:sldId xmlns:r="http://schemas.openxmlformats.org/officeDocument/2006/relationships" id="256" r:id="R47d0171aaba34f40"/>
+    <p:sldId xmlns:r="http://schemas.openxmlformats.org/officeDocument/2006/relationships" id="257" r:id="Rd918aefb40d54d62"/>
+    <p:sldId xmlns:r="http://schemas.openxmlformats.org/officeDocument/2006/relationships" id="258" r:id="R7a423c2f6c4c49f0"/>
+    <p:sldId xmlns:r="http://schemas.openxmlformats.org/officeDocument/2006/relationships" id="259" r:id="R808ac1892b924d8a"/>
+    <p:sldId xmlns:r="http://schemas.openxmlformats.org/officeDocument/2006/relationships" id="260" r:id="Rb214609aadec4398"/>
+    <p:sldId xmlns:r="http://schemas.openxmlformats.org/officeDocument/2006/relationships" id="261" r:id="Ref828d6a6bd14b9c"/>
+    <p:sldId xmlns:r="http://schemas.openxmlformats.org/officeDocument/2006/relationships" id="262" r:id="R3525e44b7dc0454f"/>
   </p:sldIdLst>
   <p:sldSz cx="12192000" cy="6858000"/>
   <p:notesSz cx="6858000" cy="9144000"/>
@@ -448,7 +448,7 @@
           <a:lstStyle xmlns:a="http://schemas.openxmlformats.org/drawingml/2006/main"/>
           <a:p xmlns:a="http://schemas.openxmlformats.org/drawingml/2006/main">
             <a:r>
-              <a:t>Created by Shivam Gupta with AI-assisted research, design, and engineering. This deck presents a pre-launch product and commercial plan. It makes no claim of real customer traction or verified deployment.</a:t>
+              <a:t>Created by Shivam Gupta with AI-assisted research, design, and engineering. This deck presents a pre-launch product and commercial plan. Live preview: https://remainder-apex.onrender.com on Render with Neon PostgreSQL. Public source: https://github.com/shi1720/evorozen . Homepage and health endpoint checked September 23. No real customer traction is claimed.</a:t>
             </a:r>
           </a:p>
         </p:txBody>
@@ -658,7 +658,7 @@
           <a:lstStyle xmlns:a="http://schemas.openxmlformats.org/drawingml/2006/main"/>
           <a:p xmlns:a="http://schemas.openxmlformats.org/drawingml/2006/main">
             <a:r>
-              <a:t>Architecture: docs/architecture.md. Validation: docs/validation-ai.md. Gemini 3.5 Flash-Lite passed live synthetic USD 216/144/72 and independent GBP 63.55/18.75/44.80 packs on 23 September 2026. This is integration evidence, not an accuracy benchmark or real customer traction. Evorozen chat adapter is implemented; sponsor inference was unavailable during testing. Separate VirtualDB CRUD probes do not prove sponsor extraction worked. Application code owns authorization, arithmetic, workflow state, and tenant-specific supplier aliases.</a:t>
+              <a:t>Architecture: docs/architecture.md. Validation: docs/validation-ai.md. Gemini 3.5 Flash-Lite passed live synthetic USD 216/144/72 and independent GBP 63.55/18.75/44.80 packs on 23 September 2026. This is integration evidence, not an accuracy benchmark or real customer traction. Evorozen chat adapter is implemented; sponsor inference was unavailable during testing. A five-request live check of the production Evorozen memory module verified a signed alias write, HMAC-validated recall, scoped deletion and absent recall afterward. This is optional sponsor memory integration, not sponsor extraction. Public validation artifacts: docs/validation-ai.md. Explicit inference selection for the deployment is Gemini. Application code owns authorization, arithmetic, workflow state, and tenant-specific supplier aliases.</a:t>
             </a:r>
           </a:p>
         </p:txBody>
@@ -868,7 +868,7 @@
           <a:lstStyle xmlns:a="http://schemas.openxmlformats.org/drawingml/2006/main"/>
           <a:p xmlns:a="http://schemas.openxmlformats.org/drawingml/2006/main">
             <a:r>
-              <a:t>Five design partners is a recruitment target, not existing users or commitments. Seven-day launch plan and outreach drafts: docs/go-to-market.md. Creator: Shivam Gupta, with AI-assisted engineering. Repository: https://github.com/shi1720/evorozen . No customer outcomes or paid revenue have been established in this deck.</a:t>
+              <a:t>Five design partners is a recruitment target, not existing users or commitments. Seven-day launch plan and outreach drafts: docs/go-to-market.md. Creator: Shivam Gupta, with AI-assisted engineering. Repository: https://github.com/shi1720/evorozen . The live preview is deployed on Render with Neon PostgreSQL. No customer outcomes or paid revenue have been established in this deck. Click the app CTA to open https://remainder-apex.onrender.com .</a:t>
             </a:r>
           </a:p>
         </p:txBody>
@@ -936,7 +936,7 @@
   </p:cSld>
   <p:clrMap bg1="lt1" tx1="dk1" bg2="lt2" tx2="dk2" accent1="accent1" accent2="accent2" accent3="accent3" accent4="accent4" accent5="accent5" accent6="accent6" hlink="hlink" folHlink="folHlink"/>
   <p:sldLayoutIdLst>
-    <p:sldLayoutId xmlns:r="http://schemas.openxmlformats.org/officeDocument/2006/relationships" id="2147483649" r:id="Red9159c4c8f14c0c"/>
+    <p:sldLayoutId xmlns:r="http://schemas.openxmlformats.org/officeDocument/2006/relationships" id="2147483649" r:id="R4a63f6d4de1b45c7"/>
   </p:sldLayoutIdLst>
   <p:txStyles>
     <p:titleStyle>
@@ -1693,7 +1693,7 @@
           <p:cNvPr id="5" name="">
             <a:extLst xmlns:a="http://schemas.openxmlformats.org/drawingml/2006/main">
               <a:ext uri="{FF2B5EF4-FFF2-40B4-BE49-F238E27FC236}">
-                <a16:creationId xmlns:a16="http://schemas.microsoft.com/office/drawing/2014/main" id="{4FCDD68A-F1D9-4CB7-BEBD-2BA837D8AC1D}"/>
+                <a16:creationId xmlns:a16="http://schemas.microsoft.com/office/drawing/2014/main" id="{2B8CEEA9-E35A-4B6B-8831-146823516697}"/>
               </a:ext>
             </a:extLst>
           </p:cNvPr>
@@ -1750,7 +1750,7 @@
           <p:cNvPr id="2" name="">
             <a:extLst xmlns:a="http://schemas.openxmlformats.org/drawingml/2006/main">
               <a:ext uri="{FF2B5EF4-FFF2-40B4-BE49-F238E27FC236}">
-                <a16:creationId xmlns:a16="http://schemas.microsoft.com/office/drawing/2014/main" id="{2FAC1C90-D596-415E-89E6-74924BA78CB2}"/>
+                <a16:creationId xmlns:a16="http://schemas.microsoft.com/office/drawing/2014/main" id="{9D7A6192-7EA6-4482-B25E-3FE3437291AA}"/>
               </a:ext>
             </a:extLst>
           </p:cNvPr>
@@ -1830,9 +1830,10 @@
           <p:cNvPr id="3" name="">
             <a:extLst xmlns:a="http://schemas.openxmlformats.org/drawingml/2006/main">
               <a:ext uri="{FF2B5EF4-FFF2-40B4-BE49-F238E27FC236}">
-                <a16:creationId xmlns:a16="http://schemas.microsoft.com/office/drawing/2014/main" id="{74111220-D0DD-4497-A8D5-5BE7D38A443C}"/>
+                <a16:creationId xmlns:a16="http://schemas.microsoft.com/office/drawing/2014/main" id="{468C7D7A-D8DE-429A-9831-5A1CC443458F}"/>
               </a:ext>
             </a:extLst>
+            <ns0:hlinkClick xmlns:ns0="http://schemas.openxmlformats.org/drawingml/2006/main" xmlns:ns1="http://schemas.openxmlformats.org/officeDocument/2006/relationships" ns1:id="rIdRemainderLink1"/>
           </p:cNvPr>
           <p:cNvSpPr>
             <a:spLocks xmlns:a="http://schemas.openxmlformats.org/drawingml/2006/main" noGrp="1"/>
@@ -1877,7 +1878,7 @@
                 <a:ea typeface="Arial"/>
                 <a:cs typeface="Arial"/>
               </a:rPr>
-              <a:t>Shivam Gupta / Evorozen Apex 2026</a:t>
+              <a:t>Shivam Gupta / remainder-apex.onrender.com</a:t>
             </a:r>
           </a:p>
         </p:txBody>
@@ -1887,7 +1888,7 @@
           <p:cNvPr id="4" name="">
             <a:extLst xmlns:a="http://schemas.openxmlformats.org/drawingml/2006/main">
               <a:ext uri="{FF2B5EF4-FFF2-40B4-BE49-F238E27FC236}">
-                <a16:creationId xmlns:a16="http://schemas.microsoft.com/office/drawing/2014/main" id="{C26D53E2-A0EC-4956-9234-B7D6AC672B1A}"/>
+                <a16:creationId xmlns:a16="http://schemas.microsoft.com/office/drawing/2014/main" id="{70F82C7F-2008-410F-A8AA-D7395BF22791}"/>
               </a:ext>
             </a:extLst>
           </p:cNvPr>
@@ -1942,7 +1943,7 @@
     </p:spTree>
     <p:extLst>
       <p:ext uri="{BB962C8B-B14F-4D97-AF65-F5344CB8AC3E}">
-        <p14:creationId xmlns:p14="http://schemas.microsoft.com/office/powerpoint/2010/main" val="572433684"/>
+        <p14:creationId xmlns:p14="http://schemas.microsoft.com/office/powerpoint/2010/main" val="1209391857"/>
       </p:ext>
     </p:extLst>
   </p:cSld>
@@ -1973,7 +1974,7 @@
           <p:cNvPr id="8" name="">
             <a:extLst xmlns:a="http://schemas.openxmlformats.org/drawingml/2006/main">
               <a:ext uri="{FF2B5EF4-FFF2-40B4-BE49-F238E27FC236}">
-                <a16:creationId xmlns:a16="http://schemas.microsoft.com/office/drawing/2014/main" id="{C6BDB4E6-01AE-4650-9693-2FD2B25F1178}"/>
+                <a16:creationId xmlns:a16="http://schemas.microsoft.com/office/drawing/2014/main" id="{05A947D7-C50B-4CFC-95D5-3D1473C9729C}"/>
               </a:ext>
             </a:extLst>
           </p:cNvPr>
@@ -2030,7 +2031,7 @@
           <p:cNvPr id="2" name="">
             <a:extLst xmlns:a="http://schemas.openxmlformats.org/drawingml/2006/main">
               <a:ext uri="{FF2B5EF4-FFF2-40B4-BE49-F238E27FC236}">
-                <a16:creationId xmlns:a16="http://schemas.microsoft.com/office/drawing/2014/main" id="{172CC00C-C6F8-4DDB-8558-7223AFE8901E}"/>
+                <a16:creationId xmlns:a16="http://schemas.microsoft.com/office/drawing/2014/main" id="{81318614-DE0A-4C14-85F9-1481D78EAF6F}"/>
               </a:ext>
             </a:extLst>
           </p:cNvPr>
@@ -2087,7 +2088,7 @@
           <p:cNvPr id="3" name="">
             <a:extLst xmlns:a="http://schemas.openxmlformats.org/drawingml/2006/main">
               <a:ext uri="{FF2B5EF4-FFF2-40B4-BE49-F238E27FC236}">
-                <a16:creationId xmlns:a16="http://schemas.microsoft.com/office/drawing/2014/main" id="{818E2160-325B-4FE3-90F6-7A9A6B538639}"/>
+                <a16:creationId xmlns:a16="http://schemas.microsoft.com/office/drawing/2014/main" id="{1C717E1B-AB34-4486-B217-A477F719020D}"/>
               </a:ext>
             </a:extLst>
           </p:cNvPr>
@@ -2167,7 +2168,7 @@
           <p:cNvPr id="4" name="">
             <a:extLst xmlns:a="http://schemas.openxmlformats.org/drawingml/2006/main">
               <a:ext uri="{FF2B5EF4-FFF2-40B4-BE49-F238E27FC236}">
-                <a16:creationId xmlns:a16="http://schemas.microsoft.com/office/drawing/2014/main" id="{9337C745-E029-4FFB-B43A-70B0284C617A}"/>
+                <a16:creationId xmlns:a16="http://schemas.microsoft.com/office/drawing/2014/main" id="{4EAD0B73-11BC-47A8-B490-585C79AAF02D}"/>
               </a:ext>
             </a:extLst>
           </p:cNvPr>
@@ -2247,7 +2248,7 @@
           <p:cNvPr id="5" name="">
             <a:extLst xmlns:a="http://schemas.openxmlformats.org/drawingml/2006/main">
               <a:ext uri="{FF2B5EF4-FFF2-40B4-BE49-F238E27FC236}">
-                <a16:creationId xmlns:a16="http://schemas.microsoft.com/office/drawing/2014/main" id="{45F89E92-F234-49EC-9413-A5B6AB7B79B2}"/>
+                <a16:creationId xmlns:a16="http://schemas.microsoft.com/office/drawing/2014/main" id="{F4022EC7-2D36-4312-B72F-C2D3E9B7AA97}"/>
               </a:ext>
             </a:extLst>
           </p:cNvPr>
@@ -2304,7 +2305,7 @@
           <p:cNvPr id="6" name="">
             <a:extLst xmlns:a="http://schemas.openxmlformats.org/drawingml/2006/main">
               <a:ext uri="{FF2B5EF4-FFF2-40B4-BE49-F238E27FC236}">
-                <a16:creationId xmlns:a16="http://schemas.microsoft.com/office/drawing/2014/main" id="{15E4FCD9-6C00-4ACC-91D1-A05DD5BDC002}"/>
+                <a16:creationId xmlns:a16="http://schemas.microsoft.com/office/drawing/2014/main" id="{679F9C4D-2E4F-4BBB-8F05-CFE3B4E38D38}"/>
               </a:ext>
             </a:extLst>
           </p:cNvPr>
@@ -2361,7 +2362,7 @@
           <p:cNvPr id="7" name="">
             <a:extLst xmlns:a="http://schemas.openxmlformats.org/drawingml/2006/main">
               <a:ext uri="{FF2B5EF4-FFF2-40B4-BE49-F238E27FC236}">
-                <a16:creationId xmlns:a16="http://schemas.microsoft.com/office/drawing/2014/main" id="{2DC43303-851E-4329-B958-28E6D31CE6FC}"/>
+                <a16:creationId xmlns:a16="http://schemas.microsoft.com/office/drawing/2014/main" id="{40F60D2F-CA0A-42E8-A025-E1D3CE4A12A9}"/>
               </a:ext>
             </a:extLst>
           </p:cNvPr>
@@ -2416,7 +2417,7 @@
     </p:spTree>
     <p:extLst>
       <p:ext uri="{BB962C8B-B14F-4D97-AF65-F5344CB8AC3E}">
-        <p14:creationId xmlns:p14="http://schemas.microsoft.com/office/powerpoint/2010/main" val="1541614791"/>
+        <p14:creationId xmlns:p14="http://schemas.microsoft.com/office/powerpoint/2010/main" val="928052862"/>
       </p:ext>
     </p:extLst>
   </p:cSld>
@@ -2447,7 +2448,7 @@
           <p:cNvPr id="9" name="">
             <a:extLst xmlns:a="http://schemas.openxmlformats.org/drawingml/2006/main">
               <a:ext uri="{FF2B5EF4-FFF2-40B4-BE49-F238E27FC236}">
-                <a16:creationId xmlns:a16="http://schemas.microsoft.com/office/drawing/2014/main" id="{2A4B04B2-EC60-4259-8002-CE010059D034}"/>
+                <a16:creationId xmlns:a16="http://schemas.microsoft.com/office/drawing/2014/main" id="{E9FA9509-960D-466F-A3BC-8AA693991DAB}"/>
               </a:ext>
             </a:extLst>
           </p:cNvPr>
@@ -2504,7 +2505,7 @@
           <p:cNvPr id="2" name="">
             <a:extLst xmlns:a="http://schemas.openxmlformats.org/drawingml/2006/main">
               <a:ext uri="{FF2B5EF4-FFF2-40B4-BE49-F238E27FC236}">
-                <a16:creationId xmlns:a16="http://schemas.microsoft.com/office/drawing/2014/main" id="{906AFCAC-1172-4D11-B7AB-109687F52009}"/>
+                <a16:creationId xmlns:a16="http://schemas.microsoft.com/office/drawing/2014/main" id="{02EC485F-3C92-4169-BFD1-66538B859176}"/>
               </a:ext>
             </a:extLst>
           </p:cNvPr>
@@ -2561,7 +2562,7 @@
           <p:cNvPr id="3" name="">
             <a:extLst xmlns:a="http://schemas.openxmlformats.org/drawingml/2006/main">
               <a:ext uri="{FF2B5EF4-FFF2-40B4-BE49-F238E27FC236}">
-                <a16:creationId xmlns:a16="http://schemas.microsoft.com/office/drawing/2014/main" id="{29AC65EC-3963-4031-8357-1A76538E0CBC}"/>
+                <a16:creationId xmlns:a16="http://schemas.microsoft.com/office/drawing/2014/main" id="{7A6435E8-5AB2-4D38-B5EC-34D4D1E66D9C}"/>
               </a:ext>
             </a:extLst>
           </p:cNvPr>
@@ -2625,7 +2626,7 @@
         </p:xfrm>
         <a:graphic xmlns:a="http://schemas.openxmlformats.org/drawingml/2006/main">
           <a:graphicData uri="http://schemas.openxmlformats.org/drawingml/2006/chart">
-            <c:chart xmlns:r="http://schemas.openxmlformats.org/officeDocument/2006/relationships" xmlns:c="http://schemas.openxmlformats.org/drawingml/2006/chart" r:id="R78c40103c62b4ecd"/>
+            <c:chart xmlns:r="http://schemas.openxmlformats.org/officeDocument/2006/relationships" xmlns:c="http://schemas.openxmlformats.org/drawingml/2006/chart" r:id="R5de3f4773a0b4e0d"/>
           </a:graphicData>
         </a:graphic>
       </p:graphicFrame>
@@ -2634,7 +2635,7 @@
           <p:cNvPr id="5" name="">
             <a:extLst xmlns:a="http://schemas.openxmlformats.org/drawingml/2006/main">
               <a:ext uri="{FF2B5EF4-FFF2-40B4-BE49-F238E27FC236}">
-                <a16:creationId xmlns:a16="http://schemas.microsoft.com/office/drawing/2014/main" id="{868E4CB5-6AD1-4E8B-9930-18EFED725E73}"/>
+                <a16:creationId xmlns:a16="http://schemas.microsoft.com/office/drawing/2014/main" id="{898DF6C1-A37A-4084-903B-2EB72C8FCE7B}"/>
               </a:ext>
             </a:extLst>
           </p:cNvPr>
@@ -2691,7 +2692,7 @@
           <p:cNvPr id="6" name="">
             <a:extLst xmlns:a="http://schemas.openxmlformats.org/drawingml/2006/main">
               <a:ext uri="{FF2B5EF4-FFF2-40B4-BE49-F238E27FC236}">
-                <a16:creationId xmlns:a16="http://schemas.microsoft.com/office/drawing/2014/main" id="{60C64BAF-DEF2-48C0-ACCF-FA1D45C2DBE7}"/>
+                <a16:creationId xmlns:a16="http://schemas.microsoft.com/office/drawing/2014/main" id="{AC0A9D3F-F9B6-4E85-84ED-E18EE88D4FC8}"/>
               </a:ext>
             </a:extLst>
           </p:cNvPr>
@@ -2748,7 +2749,7 @@
           <p:cNvPr id="7" name="">
             <a:extLst xmlns:a="http://schemas.openxmlformats.org/drawingml/2006/main">
               <a:ext uri="{FF2B5EF4-FFF2-40B4-BE49-F238E27FC236}">
-                <a16:creationId xmlns:a16="http://schemas.microsoft.com/office/drawing/2014/main" id="{5B232726-DA5B-4DEA-A025-E0A06FCB0AA8}"/>
+                <a16:creationId xmlns:a16="http://schemas.microsoft.com/office/drawing/2014/main" id="{4078A1FB-4D5B-4D88-B6E6-288057F384DE}"/>
               </a:ext>
             </a:extLst>
           </p:cNvPr>
@@ -2805,7 +2806,7 @@
           <p:cNvPr id="8" name="">
             <a:extLst xmlns:a="http://schemas.openxmlformats.org/drawingml/2006/main">
               <a:ext uri="{FF2B5EF4-FFF2-40B4-BE49-F238E27FC236}">
-                <a16:creationId xmlns:a16="http://schemas.microsoft.com/office/drawing/2014/main" id="{56E1F07F-5C90-4AE3-886C-B4D5828C1865}"/>
+                <a16:creationId xmlns:a16="http://schemas.microsoft.com/office/drawing/2014/main" id="{71A1C700-B618-4402-BB61-2AA39F758AF9}"/>
               </a:ext>
             </a:extLst>
           </p:cNvPr>
@@ -2860,7 +2861,7 @@
     </p:spTree>
     <p:extLst>
       <p:ext uri="{BB962C8B-B14F-4D97-AF65-F5344CB8AC3E}">
-        <p14:creationId xmlns:p14="http://schemas.microsoft.com/office/powerpoint/2010/main" val="120854269"/>
+        <p14:creationId xmlns:p14="http://schemas.microsoft.com/office/powerpoint/2010/main" val="1267956841"/>
       </p:ext>
     </p:extLst>
   </p:cSld>
@@ -2891,7 +2892,7 @@
           <p:cNvPr id="10" name="">
             <a:extLst xmlns:a="http://schemas.openxmlformats.org/drawingml/2006/main">
               <a:ext uri="{FF2B5EF4-FFF2-40B4-BE49-F238E27FC236}">
-                <a16:creationId xmlns:a16="http://schemas.microsoft.com/office/drawing/2014/main" id="{B7DD2F80-D108-479E-AB98-5211253E2AE0}"/>
+                <a16:creationId xmlns:a16="http://schemas.microsoft.com/office/drawing/2014/main" id="{D9A0F9E4-FDB4-432D-BF1F-1978A123BB0C}"/>
               </a:ext>
             </a:extLst>
           </p:cNvPr>
@@ -2948,7 +2949,7 @@
           <p:cNvPr id="2" name="">
             <a:extLst xmlns:a="http://schemas.openxmlformats.org/drawingml/2006/main">
               <a:ext uri="{FF2B5EF4-FFF2-40B4-BE49-F238E27FC236}">
-                <a16:creationId xmlns:a16="http://schemas.microsoft.com/office/drawing/2014/main" id="{44CCAFC8-0640-47E3-A007-19F47426610F}"/>
+                <a16:creationId xmlns:a16="http://schemas.microsoft.com/office/drawing/2014/main" id="{C379D958-94B4-4951-B6F7-16DF3BE4BD95}"/>
               </a:ext>
             </a:extLst>
           </p:cNvPr>
@@ -3005,7 +3006,7 @@
           <p:cNvPr id="3" name="">
             <a:extLst xmlns:a="http://schemas.openxmlformats.org/drawingml/2006/main">
               <a:ext uri="{FF2B5EF4-FFF2-40B4-BE49-F238E27FC236}">
-                <a16:creationId xmlns:a16="http://schemas.microsoft.com/office/drawing/2014/main" id="{75F83DA5-3D7E-489E-86BB-C4B0E7C029A1}"/>
+                <a16:creationId xmlns:a16="http://schemas.microsoft.com/office/drawing/2014/main" id="{3E974435-953D-4198-A7BD-0DC49206066F}"/>
               </a:ext>
             </a:extLst>
           </p:cNvPr>
@@ -3085,7 +3086,7 @@
           <p:cNvPr id="4" name="">
             <a:extLst xmlns:a="http://schemas.openxmlformats.org/drawingml/2006/main">
               <a:ext uri="{FF2B5EF4-FFF2-40B4-BE49-F238E27FC236}">
-                <a16:creationId xmlns:a16="http://schemas.microsoft.com/office/drawing/2014/main" id="{FF59C2FF-6B64-4670-A12C-2A3093006929}"/>
+                <a16:creationId xmlns:a16="http://schemas.microsoft.com/office/drawing/2014/main" id="{E59FCF57-B2B7-404A-895F-EA5E65CDE7FF}"/>
               </a:ext>
             </a:extLst>
           </p:cNvPr>
@@ -3142,7 +3143,7 @@
           <p:cNvPr id="5" name="">
             <a:extLst xmlns:a="http://schemas.openxmlformats.org/drawingml/2006/main">
               <a:ext uri="{FF2B5EF4-FFF2-40B4-BE49-F238E27FC236}">
-                <a16:creationId xmlns:a16="http://schemas.microsoft.com/office/drawing/2014/main" id="{11774B5E-8E90-4B35-9211-0C28DF48F5B9}"/>
+                <a16:creationId xmlns:a16="http://schemas.microsoft.com/office/drawing/2014/main" id="{CD3A900B-B586-44EE-B217-17B3E3BFC92E}"/>
               </a:ext>
             </a:extLst>
           </p:cNvPr>
@@ -3189,7 +3190,7 @@
                 <a:ea typeface="Arial"/>
                 <a:cs typeface="Arial"/>
               </a:rPr>
-              <a:t>The user checks exact source quotations</a:t>
+              <a:t>The owner checks source quotations.</a:t>
             </a:r>
           </a:p>
           <a:p xmlns:a="http://schemas.openxmlformats.org/drawingml/2006/main">
@@ -3212,7 +3213,7 @@
                 <a:ea typeface="Arial"/>
                 <a:cs typeface="Arial"/>
               </a:rPr>
-              <a:t>before approving a claim.</a:t>
+              <a:t>Signed Evorozen aliases aid later cases.</a:t>
             </a:r>
           </a:p>
         </p:txBody>
@@ -3222,7 +3223,7 @@
           <p:cNvPr id="6" name="">
             <a:extLst xmlns:a="http://schemas.openxmlformats.org/drawingml/2006/main">
               <a:ext uri="{FF2B5EF4-FFF2-40B4-BE49-F238E27FC236}">
-                <a16:creationId xmlns:a16="http://schemas.microsoft.com/office/drawing/2014/main" id="{C5F29FE7-A418-4C97-A561-94E7A84B2991}"/>
+                <a16:creationId xmlns:a16="http://schemas.microsoft.com/office/drawing/2014/main" id="{CC35C615-2B44-4B9A-A800-90829E22E6FD}"/>
               </a:ext>
             </a:extLst>
           </p:cNvPr>
@@ -3279,7 +3280,7 @@
           <p:cNvPr id="7" name="">
             <a:extLst xmlns:a="http://schemas.openxmlformats.org/drawingml/2006/main">
               <a:ext uri="{FF2B5EF4-FFF2-40B4-BE49-F238E27FC236}">
-                <a16:creationId xmlns:a16="http://schemas.microsoft.com/office/drawing/2014/main" id="{C00CC0A6-C404-4582-ADAA-E28A828B5942}"/>
+                <a16:creationId xmlns:a16="http://schemas.microsoft.com/office/drawing/2014/main" id="{F7B0C0CB-C42B-4D5B-B061-F73D2080DB61}"/>
               </a:ext>
             </a:extLst>
           </p:cNvPr>
@@ -3359,7 +3360,7 @@
           <p:cNvPr id="8" name="">
             <a:extLst xmlns:a="http://schemas.openxmlformats.org/drawingml/2006/main">
               <a:ext uri="{FF2B5EF4-FFF2-40B4-BE49-F238E27FC236}">
-                <a16:creationId xmlns:a16="http://schemas.microsoft.com/office/drawing/2014/main" id="{A2A9FBCB-ED4A-42DA-BC0A-785BD2675AF7}"/>
+                <a16:creationId xmlns:a16="http://schemas.microsoft.com/office/drawing/2014/main" id="{706CFA19-E8E1-4C24-8ACA-1D60A7A3CFB2}"/>
               </a:ext>
             </a:extLst>
           </p:cNvPr>
@@ -3406,7 +3407,7 @@
                 <a:ea typeface="Arial"/>
                 <a:cs typeface="Arial"/>
               </a:rPr>
-              <a:t>Gemini live checks passed on 2 synthetic packs. Sample walkthrough uses replay.</a:t>
+              <a:t>Gemini extraction + signed Evorozen memory verified. Sample footage uses replay.</a:t>
             </a:r>
           </a:p>
         </p:txBody>
@@ -3416,7 +3417,7 @@
           <p:cNvPr id="9" name="">
             <a:extLst xmlns:a="http://schemas.openxmlformats.org/drawingml/2006/main">
               <a:ext uri="{FF2B5EF4-FFF2-40B4-BE49-F238E27FC236}">
-                <a16:creationId xmlns:a16="http://schemas.microsoft.com/office/drawing/2014/main" id="{A3074574-0145-43DD-966A-4D6859A37A9D}"/>
+                <a16:creationId xmlns:a16="http://schemas.microsoft.com/office/drawing/2014/main" id="{D952B965-DD48-44B6-A823-A5A6DD8E7581}"/>
               </a:ext>
             </a:extLst>
           </p:cNvPr>
@@ -3471,7 +3472,7 @@
     </p:spTree>
     <p:extLst>
       <p:ext uri="{BB962C8B-B14F-4D97-AF65-F5344CB8AC3E}">
-        <p14:creationId xmlns:p14="http://schemas.microsoft.com/office/powerpoint/2010/main" val="721923055"/>
+        <p14:creationId xmlns:p14="http://schemas.microsoft.com/office/powerpoint/2010/main" val="1563049283"/>
       </p:ext>
     </p:extLst>
   </p:cSld>
@@ -3502,7 +3503,7 @@
           <p:cNvPr id="7" name="">
             <a:extLst xmlns:a="http://schemas.openxmlformats.org/drawingml/2006/main">
               <a:ext uri="{FF2B5EF4-FFF2-40B4-BE49-F238E27FC236}">
-                <a16:creationId xmlns:a16="http://schemas.microsoft.com/office/drawing/2014/main" id="{C150D605-2FE2-48A3-A3A1-515BF857820C}"/>
+                <a16:creationId xmlns:a16="http://schemas.microsoft.com/office/drawing/2014/main" id="{C79A5D9E-F9B3-4D97-8E15-B690962070AD}"/>
               </a:ext>
             </a:extLst>
           </p:cNvPr>
@@ -3559,7 +3560,7 @@
           <p:cNvPr id="2" name="">
             <a:extLst xmlns:a="http://schemas.openxmlformats.org/drawingml/2006/main">
               <a:ext uri="{FF2B5EF4-FFF2-40B4-BE49-F238E27FC236}">
-                <a16:creationId xmlns:a16="http://schemas.microsoft.com/office/drawing/2014/main" id="{9CFDE5CE-364B-425A-8C82-04985ACA9625}"/>
+                <a16:creationId xmlns:a16="http://schemas.microsoft.com/office/drawing/2014/main" id="{CA0D2088-2476-4B42-BCFA-273B49E27EE0}"/>
               </a:ext>
             </a:extLst>
           </p:cNvPr>
@@ -3639,7 +3640,7 @@
           <p:cNvPr id="3" name="">
             <a:extLst xmlns:a="http://schemas.openxmlformats.org/drawingml/2006/main">
               <a:ext uri="{FF2B5EF4-FFF2-40B4-BE49-F238E27FC236}">
-                <a16:creationId xmlns:a16="http://schemas.microsoft.com/office/drawing/2014/main" id="{8F6B4570-47D2-488A-BF88-5811F8D4A12B}"/>
+                <a16:creationId xmlns:a16="http://schemas.microsoft.com/office/drawing/2014/main" id="{303B84DA-3D2C-4E14-A428-B13A9C220C1E}"/>
               </a:ext>
             </a:extLst>
           </p:cNvPr>
@@ -3742,7 +3743,7 @@
           <p:cNvPr id="4" name="">
             <a:extLst xmlns:a="http://schemas.openxmlformats.org/drawingml/2006/main">
               <a:ext uri="{FF2B5EF4-FFF2-40B4-BE49-F238E27FC236}">
-                <a16:creationId xmlns:a16="http://schemas.microsoft.com/office/drawing/2014/main" id="{2FA41B8D-D6D8-4FA2-B00A-7706E74D87CA}"/>
+                <a16:creationId xmlns:a16="http://schemas.microsoft.com/office/drawing/2014/main" id="{F8AF7571-FB9E-4F40-AA4C-56E7F020C24B}"/>
               </a:ext>
             </a:extLst>
           </p:cNvPr>
@@ -3845,7 +3846,7 @@
           <p:cNvPr id="5" name="">
             <a:extLst xmlns:a="http://schemas.openxmlformats.org/drawingml/2006/main">
               <a:ext uri="{FF2B5EF4-FFF2-40B4-BE49-F238E27FC236}">
-                <a16:creationId xmlns:a16="http://schemas.microsoft.com/office/drawing/2014/main" id="{63071F30-9CF1-4582-A23F-310D4924805C}"/>
+                <a16:creationId xmlns:a16="http://schemas.microsoft.com/office/drawing/2014/main" id="{D0C07F12-3B1B-48A2-A876-A31347B1213C}"/>
               </a:ext>
             </a:extLst>
           </p:cNvPr>
@@ -3902,7 +3903,7 @@
           <p:cNvPr id="6" name="">
             <a:extLst xmlns:a="http://schemas.openxmlformats.org/drawingml/2006/main">
               <a:ext uri="{FF2B5EF4-FFF2-40B4-BE49-F238E27FC236}">
-                <a16:creationId xmlns:a16="http://schemas.microsoft.com/office/drawing/2014/main" id="{68CEE7BA-059C-40CE-9B3A-9BB0C23BE854}"/>
+                <a16:creationId xmlns:a16="http://schemas.microsoft.com/office/drawing/2014/main" id="{71829E3F-A0E4-41B0-9A5B-A934EE389E25}"/>
               </a:ext>
             </a:extLst>
           </p:cNvPr>
@@ -3957,7 +3958,7 @@
     </p:spTree>
     <p:extLst>
       <p:ext uri="{BB962C8B-B14F-4D97-AF65-F5344CB8AC3E}">
-        <p14:creationId xmlns:p14="http://schemas.microsoft.com/office/powerpoint/2010/main" val="169869900"/>
+        <p14:creationId xmlns:p14="http://schemas.microsoft.com/office/powerpoint/2010/main" val="1991857087"/>
       </p:ext>
     </p:extLst>
   </p:cSld>
@@ -3988,7 +3989,7 @@
           <p:cNvPr id="8" name="">
             <a:extLst xmlns:a="http://schemas.openxmlformats.org/drawingml/2006/main">
               <a:ext uri="{FF2B5EF4-FFF2-40B4-BE49-F238E27FC236}">
-                <a16:creationId xmlns:a16="http://schemas.microsoft.com/office/drawing/2014/main" id="{F789D7C8-DA02-427F-9881-251202CAA5C7}"/>
+                <a16:creationId xmlns:a16="http://schemas.microsoft.com/office/drawing/2014/main" id="{11775A4B-3052-4FCC-8C7C-6D86E5F8A59F}"/>
               </a:ext>
             </a:extLst>
           </p:cNvPr>
@@ -4045,7 +4046,7 @@
           <p:cNvPr id="2" name="">
             <a:extLst xmlns:a="http://schemas.openxmlformats.org/drawingml/2006/main">
               <a:ext uri="{FF2B5EF4-FFF2-40B4-BE49-F238E27FC236}">
-                <a16:creationId xmlns:a16="http://schemas.microsoft.com/office/drawing/2014/main" id="{05BA12D6-6D51-4F1C-9093-60ACAFF15C93}"/>
+                <a16:creationId xmlns:a16="http://schemas.microsoft.com/office/drawing/2014/main" id="{8FD59A5A-7658-421C-B6AF-8FB6424080D2}"/>
               </a:ext>
             </a:extLst>
           </p:cNvPr>
@@ -4102,7 +4103,7 @@
           <p:cNvPr id="3" name="">
             <a:extLst xmlns:a="http://schemas.openxmlformats.org/drawingml/2006/main">
               <a:ext uri="{FF2B5EF4-FFF2-40B4-BE49-F238E27FC236}">
-                <a16:creationId xmlns:a16="http://schemas.microsoft.com/office/drawing/2014/main" id="{1E5D2F85-DD87-4B0E-ACB6-D42898733D25}"/>
+                <a16:creationId xmlns:a16="http://schemas.microsoft.com/office/drawing/2014/main" id="{39AF666A-88D5-4F2C-8B1C-52256D4412F7}"/>
               </a:ext>
             </a:extLst>
           </p:cNvPr>
@@ -4159,7 +4160,7 @@
           <p:cNvPr id="4" name="">
             <a:extLst xmlns:a="http://schemas.openxmlformats.org/drawingml/2006/main">
               <a:ext uri="{FF2B5EF4-FFF2-40B4-BE49-F238E27FC236}">
-                <a16:creationId xmlns:a16="http://schemas.microsoft.com/office/drawing/2014/main" id="{5F666A57-5393-4355-8951-B5C28D583718}"/>
+                <a16:creationId xmlns:a16="http://schemas.microsoft.com/office/drawing/2014/main" id="{AD60E79F-24D7-49AA-8B60-90CE3B7417AD}"/>
               </a:ext>
             </a:extLst>
           </p:cNvPr>
@@ -4239,7 +4240,7 @@
           <p:cNvPr id="5" name="">
             <a:extLst xmlns:a="http://schemas.openxmlformats.org/drawingml/2006/main">
               <a:ext uri="{FF2B5EF4-FFF2-40B4-BE49-F238E27FC236}">
-                <a16:creationId xmlns:a16="http://schemas.microsoft.com/office/drawing/2014/main" id="{70A03D6A-15D4-4546-A561-F6A1FF80E308}"/>
+                <a16:creationId xmlns:a16="http://schemas.microsoft.com/office/drawing/2014/main" id="{287C8AC4-6037-4EA9-B6AF-EF1EB53073D7}"/>
               </a:ext>
             </a:extLst>
           </p:cNvPr>
@@ -4342,7 +4343,7 @@
           <p:cNvPr id="6" name="">
             <a:extLst xmlns:a="http://schemas.openxmlformats.org/drawingml/2006/main">
               <a:ext uri="{FF2B5EF4-FFF2-40B4-BE49-F238E27FC236}">
-                <a16:creationId xmlns:a16="http://schemas.microsoft.com/office/drawing/2014/main" id="{45E700EF-8D2C-4D5B-9E6A-67E08E03BBE3}"/>
+                <a16:creationId xmlns:a16="http://schemas.microsoft.com/office/drawing/2014/main" id="{05C5934B-87D8-4533-9146-69C544026029}"/>
               </a:ext>
             </a:extLst>
           </p:cNvPr>
@@ -4399,7 +4400,7 @@
           <p:cNvPr id="7" name="">
             <a:extLst xmlns:a="http://schemas.openxmlformats.org/drawingml/2006/main">
               <a:ext uri="{FF2B5EF4-FFF2-40B4-BE49-F238E27FC236}">
-                <a16:creationId xmlns:a16="http://schemas.microsoft.com/office/drawing/2014/main" id="{8ABBE23F-8A59-40E5-BD02-A6B33A7664F2}"/>
+                <a16:creationId xmlns:a16="http://schemas.microsoft.com/office/drawing/2014/main" id="{44B74206-06CB-4E76-9A7E-5750088B0A67}"/>
               </a:ext>
             </a:extLst>
           </p:cNvPr>
@@ -4454,7 +4455,7 @@
     </p:spTree>
     <p:extLst>
       <p:ext uri="{BB962C8B-B14F-4D97-AF65-F5344CB8AC3E}">
-        <p14:creationId xmlns:p14="http://schemas.microsoft.com/office/powerpoint/2010/main" val="941736753"/>
+        <p14:creationId xmlns:p14="http://schemas.microsoft.com/office/powerpoint/2010/main" val="121508953"/>
       </p:ext>
     </p:extLst>
   </p:cSld>
@@ -4482,10 +4483,10 @@
       </p:grpSpPr>
       <p:sp>
         <p:nvSpPr>
-          <p:cNvPr id="6" name="">
+          <p:cNvPr id="7" name="">
             <a:extLst xmlns:a="http://schemas.openxmlformats.org/drawingml/2006/main">
               <a:ext uri="{FF2B5EF4-FFF2-40B4-BE49-F238E27FC236}">
-                <a16:creationId xmlns:a16="http://schemas.microsoft.com/office/drawing/2014/main" id="{C1CA32AB-EA4D-425A-AA9B-D993C67DDD19}"/>
+                <a16:creationId xmlns:a16="http://schemas.microsoft.com/office/drawing/2014/main" id="{170E695D-732D-436F-9583-D27AD9F5C17C}"/>
               </a:ext>
             </a:extLst>
           </p:cNvPr>
@@ -4565,7 +4566,7 @@
           <p:cNvPr id="2" name="">
             <a:extLst xmlns:a="http://schemas.openxmlformats.org/drawingml/2006/main">
               <a:ext uri="{FF2B5EF4-FFF2-40B4-BE49-F238E27FC236}">
-                <a16:creationId xmlns:a16="http://schemas.microsoft.com/office/drawing/2014/main" id="{A52B0A46-8FA1-4BCA-B126-C6EC69E20C7A}"/>
+                <a16:creationId xmlns:a16="http://schemas.microsoft.com/office/drawing/2014/main" id="{83F2DE22-BADF-43DB-A51B-BCFDDCF7FE85}"/>
               </a:ext>
             </a:extLst>
           </p:cNvPr>
@@ -4622,7 +4623,7 @@
           <p:cNvPr id="3" name="">
             <a:extLst xmlns:a="http://schemas.openxmlformats.org/drawingml/2006/main">
               <a:ext uri="{FF2B5EF4-FFF2-40B4-BE49-F238E27FC236}">
-                <a16:creationId xmlns:a16="http://schemas.microsoft.com/office/drawing/2014/main" id="{8A10EBB9-5CAD-4C0C-8674-A8033C917603}"/>
+                <a16:creationId xmlns:a16="http://schemas.microsoft.com/office/drawing/2014/main" id="{E54916AC-1C8D-4476-B9F9-E73768B05386}"/>
               </a:ext>
             </a:extLst>
           </p:cNvPr>
@@ -4725,9 +4726,68 @@
           <p:cNvPr id="4" name="">
             <a:extLst xmlns:a="http://schemas.openxmlformats.org/drawingml/2006/main">
               <a:ext uri="{FF2B5EF4-FFF2-40B4-BE49-F238E27FC236}">
-                <a16:creationId xmlns:a16="http://schemas.microsoft.com/office/drawing/2014/main" id="{290D2273-D1AA-44F7-8AB0-207D5B47434C}"/>
+                <a16:creationId xmlns:a16="http://schemas.microsoft.com/office/drawing/2014/main" id="{E80DF654-BDD0-45A4-8BEE-C1E0DE5367A2}"/>
               </a:ext>
             </a:extLst>
+            <ns0:hlinkClick xmlns:ns0="http://schemas.openxmlformats.org/drawingml/2006/main" xmlns:ns1="http://schemas.openxmlformats.org/officeDocument/2006/relationships" ns1:id="rIdRemainderLink2"/>
+          </p:cNvPr>
+          <p:cNvSpPr>
+            <a:spLocks xmlns:a="http://schemas.openxmlformats.org/drawingml/2006/main" noGrp="1"/>
+          </p:cNvSpPr>
+          <p:nvPr/>
+        </p:nvSpPr>
+        <p:spPr>
+          <a:xfrm xmlns:a="http://schemas.openxmlformats.org/drawingml/2006/main">
+            <a:off x="800100" y="5562600"/>
+            <a:ext cx="10287000" cy="419100"/>
+          </a:xfrm>
+          <a:prstGeom xmlns:a="http://schemas.openxmlformats.org/drawingml/2006/main" prst="rect">
+            <a:avLst/>
+          </a:prstGeom>
+          <a:noFill xmlns:a="http://schemas.openxmlformats.org/drawingml/2006/main"/>
+          <a:ln xmlns:a="http://schemas.openxmlformats.org/drawingml/2006/main" w="0">
+            <a:noFill/>
+          </a:ln>
+        </p:spPr>
+        <p:txBody>
+          <a:bodyPr xmlns:a="http://schemas.openxmlformats.org/drawingml/2006/main" wrap="square" lIns="0" tIns="0" rIns="0" bIns="0" anchor="t">
+            <a:noAutofit/>
+          </a:bodyPr>
+          <a:lstStyle xmlns:a="http://schemas.openxmlformats.org/drawingml/2006/main"/>
+          <a:p xmlns:a="http://schemas.openxmlformats.org/drawingml/2006/main">
+            <a:pPr>
+              <a:defRPr sz="2100" b="1">
+                <a:solidFill>
+                  <a:srgbClr val="D9EBDF"/>
+                </a:solidFill>
+                <a:latin typeface="Arial"/>
+                <a:ea typeface="Arial"/>
+                <a:cs typeface="Arial"/>
+              </a:defRPr>
+            </a:pPr>
+            <a:r>
+              <a:rPr sz="2100" b="1">
+                <a:solidFill>
+                  <a:srgbClr val="D9EBDF"/>
+                </a:solidFill>
+                <a:latin typeface="Arial"/>
+                <a:ea typeface="Arial"/>
+                <a:cs typeface="Arial"/>
+              </a:rPr>
+              <a:t>remainder-apex.onrender.com →</a:t>
+            </a:r>
+          </a:p>
+        </p:txBody>
+      </p:sp>
+      <p:sp>
+        <p:nvSpPr>
+          <p:cNvPr id="5" name="">
+            <a:extLst xmlns:a="http://schemas.openxmlformats.org/drawingml/2006/main">
+              <a:ext uri="{FF2B5EF4-FFF2-40B4-BE49-F238E27FC236}">
+                <a16:creationId xmlns:a16="http://schemas.microsoft.com/office/drawing/2014/main" id="{92019A81-EF1E-4E1C-A51F-90A08D9D7A28}"/>
+              </a:ext>
+            </a:extLst>
+            <ns2:hlinkClick xmlns:ns2="http://schemas.openxmlformats.org/drawingml/2006/main" xmlns:ns3="http://schemas.openxmlformats.org/officeDocument/2006/relationships" ns3:id="rIdRemainderLink3"/>
           </p:cNvPr>
           <p:cNvSpPr>
             <a:spLocks xmlns:a="http://schemas.openxmlformats.org/drawingml/2006/main" noGrp="1"/>
@@ -4772,17 +4832,17 @@
                 <a:ea typeface="Arial"/>
                 <a:cs typeface="Arial"/>
               </a:rPr>
-              <a:t>Pre-launch plan / github.com/shi1720/evorozen</a:t>
-            </a:r>
-          </a:p>
-        </p:txBody>
-      </p:sp>
-      <p:sp>
-        <p:nvSpPr>
-          <p:cNvPr id="5" name="">
+              <a:t>Public source / github.com/shi1720/evorozen</a:t>
+            </a:r>
+          </a:p>
+        </p:txBody>
+      </p:sp>
+      <p:sp>
+        <p:nvSpPr>
+          <p:cNvPr id="6" name="">
             <a:extLst xmlns:a="http://schemas.openxmlformats.org/drawingml/2006/main">
               <a:ext uri="{FF2B5EF4-FFF2-40B4-BE49-F238E27FC236}">
-                <a16:creationId xmlns:a16="http://schemas.microsoft.com/office/drawing/2014/main" id="{FBB9B436-26D3-46A7-9BA1-003F69BA6BBA}"/>
+                <a16:creationId xmlns:a16="http://schemas.microsoft.com/office/drawing/2014/main" id="{25AB16EA-1205-4F2C-A13F-C578766939FF}"/>
               </a:ext>
             </a:extLst>
           </p:cNvPr>
@@ -4837,7 +4897,7 @@
     </p:spTree>
     <p:extLst>
       <p:ext uri="{BB962C8B-B14F-4D97-AF65-F5344CB8AC3E}">
-        <p14:creationId xmlns:p14="http://schemas.microsoft.com/office/powerpoint/2010/main" val="106205032"/>
+        <p14:creationId xmlns:p14="http://schemas.microsoft.com/office/powerpoint/2010/main" val="727334325"/>
       </p:ext>
     </p:extLst>
   </p:cSld>

</xml_diff>

<commit_message>
Fix recovery screen reset and refresh final demo and pitch materials
</commit_message>
<xml_diff>
--- a/deliverables/remainder-pitch.pptx
+++ b/deliverables/remainder-pitch.pptx
@@ -2,19 +2,19 @@
 <file path=ppt/presentation.xml><?xml version="1.0" encoding="utf-8"?>
 <p:presentation xmlns:p="http://schemas.openxmlformats.org/presentationml/2006/main">
   <p:sldMasterIdLst>
-    <p:sldMasterId xmlns:r="http://schemas.openxmlformats.org/officeDocument/2006/relationships" id="2147483648" r:id="R6dce5656c5124ac9"/>
+    <p:sldMasterId xmlns:r="http://schemas.openxmlformats.org/officeDocument/2006/relationships" id="2147483648" r:id="R0e9a6a853377450f"/>
   </p:sldMasterIdLst>
   <p:notesMasterIdLst>
-    <p:notesMasterId xmlns:r="http://schemas.openxmlformats.org/officeDocument/2006/relationships" r:id="R7c7731b47cef461e"/>
+    <p:notesMasterId xmlns:r="http://schemas.openxmlformats.org/officeDocument/2006/relationships" r:id="Rd31867199a504003"/>
   </p:notesMasterIdLst>
   <p:sldIdLst>
-    <p:sldId xmlns:r="http://schemas.openxmlformats.org/officeDocument/2006/relationships" id="256" r:id="R47d0171aaba34f40"/>
-    <p:sldId xmlns:r="http://schemas.openxmlformats.org/officeDocument/2006/relationships" id="257" r:id="Rd918aefb40d54d62"/>
-    <p:sldId xmlns:r="http://schemas.openxmlformats.org/officeDocument/2006/relationships" id="258" r:id="R7a423c2f6c4c49f0"/>
-    <p:sldId xmlns:r="http://schemas.openxmlformats.org/officeDocument/2006/relationships" id="259" r:id="R808ac1892b924d8a"/>
-    <p:sldId xmlns:r="http://schemas.openxmlformats.org/officeDocument/2006/relationships" id="260" r:id="Rb214609aadec4398"/>
-    <p:sldId xmlns:r="http://schemas.openxmlformats.org/officeDocument/2006/relationships" id="261" r:id="Ref828d6a6bd14b9c"/>
-    <p:sldId xmlns:r="http://schemas.openxmlformats.org/officeDocument/2006/relationships" id="262" r:id="R3525e44b7dc0454f"/>
+    <p:sldId xmlns:r="http://schemas.openxmlformats.org/officeDocument/2006/relationships" id="256" r:id="Rbf4976a0baeb4086"/>
+    <p:sldId xmlns:r="http://schemas.openxmlformats.org/officeDocument/2006/relationships" id="257" r:id="Ref483a99cceb4ea8"/>
+    <p:sldId xmlns:r="http://schemas.openxmlformats.org/officeDocument/2006/relationships" id="258" r:id="R4c8de23f91ba4483"/>
+    <p:sldId xmlns:r="http://schemas.openxmlformats.org/officeDocument/2006/relationships" id="259" r:id="R891ce60c7b8b49ee"/>
+    <p:sldId xmlns:r="http://schemas.openxmlformats.org/officeDocument/2006/relationships" id="260" r:id="R53589c0473974d69"/>
+    <p:sldId xmlns:r="http://schemas.openxmlformats.org/officeDocument/2006/relationships" id="261" r:id="R499069fcbd584ebd"/>
+    <p:sldId xmlns:r="http://schemas.openxmlformats.org/officeDocument/2006/relationships" id="262" r:id="Rad55a07690c54d41"/>
   </p:sldIdLst>
   <p:sldSz cx="12192000" cy="6858000"/>
   <p:notesSz cx="6858000" cy="9144000"/>
@@ -448,7 +448,7 @@
           <a:lstStyle xmlns:a="http://schemas.openxmlformats.org/drawingml/2006/main"/>
           <a:p xmlns:a="http://schemas.openxmlformats.org/drawingml/2006/main">
             <a:r>
-              <a:t>Created by Shivam Gupta with AI-assisted research, design, and engineering. This deck presents a pre-launch product and commercial plan. Live preview: https://remainder-apex.onrender.com on Render with Neon PostgreSQL. Public source: https://github.com/shi1720/evorozen . Homepage and health endpoint checked September 23. No real customer traction is claimed.</a:t>
+              <a:t>Created by Shivam Gupta with AI-assisted research, design, and engineering. This deck presents a deployed product and a commercial plan awaiting customer validation. Live app: https://remainder-desk.web.app on Firebase Hosting, Cloud Run, and Neon PostgreSQL. Public source: https://github.com/shi1720/evorozen . Hosted workflow evidence: docs/validation/firebase-browser-workflow.json. The final narrated film uses actual OpenAI calls in a normal account with fictional documents; see docs/validation-video.md. No real customer traction is claimed.</a:t>
             </a:r>
           </a:p>
         </p:txBody>
@@ -658,7 +658,7 @@
           <a:lstStyle xmlns:a="http://schemas.openxmlformats.org/drawingml/2006/main"/>
           <a:p xmlns:a="http://schemas.openxmlformats.org/drawingml/2006/main">
             <a:r>
-              <a:t>Architecture: docs/architecture.md. Validation: docs/validation-ai.md. Gemini 3.5 Flash-Lite passed live synthetic USD 216/144/72 and independent GBP 63.55/18.75/44.80 packs on 23 September 2026. This is integration evidence, not an accuracy benchmark or real customer traction. Evorozen chat adapter is implemented; sponsor inference was unavailable during testing. A five-request live check of the production Evorozen memory module verified a signed alias write, HMAC-validated recall, scoped deletion and absent recall afterward. This is optional sponsor memory integration, not sponsor extraction. Public validation artifacts: docs/validation-ai.md. Explicit inference selection for the deployment is Gemini. Application code owns authorization, arithmetic, workflow state, and tenant-specific supplier aliases.</a:t>
+              <a:t>Architecture: docs/architecture.md. Validation: docs/validation-ai.md and docs/validation-video.md. OpenAI gpt-5.4-mini passed six fixed synthetic evaluation cases with no missed expected findings or wrong supported amounts, plus USD 216/144/72 and independent GBP 63.55/18.75/44.80 integration checks on 23 September 2026. One overdelivery produced an unnecessary blocked review card. These are bounded integration checks, not a general accuracy claim or customer traction. The narrated film follows a normal account through an initial real OpenAI request, approval of a $216 claim, upload of a $144 credit note, and a second real OpenAI request showing $72 outstanding. An independent five-request live check of the optional Evorozen memory module verified a signed alias write, HMAC-validated recall, scoped deletion and absent recall afterward. Sponsor memory was disabled in the film to keep its separate evidence clear. The Evorozen inference adapter remains implemented; sponsor inference was unavailable during testing. Application code owns authorization, arithmetic, workflow state, and tenant-specific supplier aliases.</a:t>
             </a:r>
           </a:p>
         </p:txBody>
@@ -798,7 +798,7 @@
           <a:lstStyle xmlns:a="http://schemas.openxmlformats.org/drawingml/2006/main"/>
           <a:p xmlns:a="http://schemas.openxmlformats.org/drawingml/2006/main">
             <a:r>
-              <a:t>Price and allowance are proposed, not verified willingness to pay or implemented subscription billing. Unit-economics sensitivities and exclusions are in docs/go-to-market.md. Evorozen offer reviewed September 23, 2026: https://pulse.evorozen.com/dashboard says first 50 calls free, no card needed. It does not state a recurring monthly allowance. Paid API cost remains unverified. The sponsor adapter can use multiple extraction windows per analysis due to a 2,000-character prompt limit. Each outbound window and fallback consumes a call; do not assume two analyses equal two calls. At the illustrative $0.025/call, 100 packs with two analyses and 10 percent retries cost $5.50 in AI at one window per analysis, or $44 at eight windows, before other costs. See docs/go-to-market.md for assumptions.</a:t>
+              <a:t>Price and allowance are proposed, not verified willingness to pay or implemented subscription billing. Unit-economics sensitivities and exclusions are in docs/go-to-market.md. Production inference uses OpenAI gpt-5.4-mini. Measure actual input and output tokens, retries, hosting, support time, and optional Evorozen memory traffic before offering a fixed allowance. Application request caps bound usage; they are not a live provider balance. The optional sponsor integration has separate verified memory behavior, but no verified production paid tariff. Existing sponsor-call sensitivity tables are scenario planning, not measured OpenAI cost. Start with a small guided pilot and an agreed request budget.</a:t>
             </a:r>
           </a:p>
         </p:txBody>
@@ -868,7 +868,7 @@
           <a:lstStyle xmlns:a="http://schemas.openxmlformats.org/drawingml/2006/main"/>
           <a:p xmlns:a="http://schemas.openxmlformats.org/drawingml/2006/main">
             <a:r>
-              <a:t>Five design partners is a recruitment target, not existing users or commitments. Seven-day launch plan and outreach drafts: docs/go-to-market.md. Creator: Shivam Gupta, with AI-assisted engineering. Repository: https://github.com/shi1720/evorozen . The live preview is deployed on Render with Neon PostgreSQL. No customer outcomes or paid revenue have been established in this deck. Click the app CTA to open https://remainder-apex.onrender.com .</a:t>
+              <a:t>Five design partners is a recruitment target, not existing users or commitments. Seven-day launch plan and outreach drafts: docs/go-to-market.md. Creator: Shivam Gupta, with AI-assisted engineering. Repository: https://github.com/shi1720/evorozen . The live app is deployed on Firebase Hosting with Cloud Run and Neon PostgreSQL. No customer outcomes or paid revenue have been established in this deck. Click the app CTA to open https://remainder-desk.web.app .</a:t>
             </a:r>
           </a:p>
         </p:txBody>
@@ -936,7 +936,7 @@
   </p:cSld>
   <p:clrMap bg1="lt1" tx1="dk1" bg2="lt2" tx2="dk2" accent1="accent1" accent2="accent2" accent3="accent3" accent4="accent4" accent5="accent5" accent6="accent6" hlink="hlink" folHlink="folHlink"/>
   <p:sldLayoutIdLst>
-    <p:sldLayoutId xmlns:r="http://schemas.openxmlformats.org/officeDocument/2006/relationships" id="2147483649" r:id="R4a63f6d4de1b45c7"/>
+    <p:sldLayoutId xmlns:r="http://schemas.openxmlformats.org/officeDocument/2006/relationships" id="2147483649" r:id="R0fae21912766472f"/>
   </p:sldLayoutIdLst>
   <p:txStyles>
     <p:titleStyle>
@@ -1693,7 +1693,7 @@
           <p:cNvPr id="5" name="">
             <a:extLst xmlns:a="http://schemas.openxmlformats.org/drawingml/2006/main">
               <a:ext uri="{FF2B5EF4-FFF2-40B4-BE49-F238E27FC236}">
-                <a16:creationId xmlns:a16="http://schemas.microsoft.com/office/drawing/2014/main" id="{2B8CEEA9-E35A-4B6B-8831-146823516697}"/>
+                <a16:creationId xmlns:a16="http://schemas.microsoft.com/office/drawing/2014/main" id="{771AF251-7C71-438B-BF62-9A6095AD1AF8}"/>
               </a:ext>
             </a:extLst>
           </p:cNvPr>
@@ -1750,7 +1750,7 @@
           <p:cNvPr id="2" name="">
             <a:extLst xmlns:a="http://schemas.openxmlformats.org/drawingml/2006/main">
               <a:ext uri="{FF2B5EF4-FFF2-40B4-BE49-F238E27FC236}">
-                <a16:creationId xmlns:a16="http://schemas.microsoft.com/office/drawing/2014/main" id="{9D7A6192-7EA6-4482-B25E-3FE3437291AA}"/>
+                <a16:creationId xmlns:a16="http://schemas.microsoft.com/office/drawing/2014/main" id="{C092C705-EB9D-432A-AA3D-DC43A69CDC6A}"/>
               </a:ext>
             </a:extLst>
           </p:cNvPr>
@@ -1830,7 +1830,7 @@
           <p:cNvPr id="3" name="">
             <a:extLst xmlns:a="http://schemas.openxmlformats.org/drawingml/2006/main">
               <a:ext uri="{FF2B5EF4-FFF2-40B4-BE49-F238E27FC236}">
-                <a16:creationId xmlns:a16="http://schemas.microsoft.com/office/drawing/2014/main" id="{468C7D7A-D8DE-429A-9831-5A1CC443458F}"/>
+                <a16:creationId xmlns:a16="http://schemas.microsoft.com/office/drawing/2014/main" id="{2436CC46-3384-46D5-97CC-4B7023A9D6B4}"/>
               </a:ext>
             </a:extLst>
             <ns0:hlinkClick xmlns:ns0="http://schemas.openxmlformats.org/drawingml/2006/main" xmlns:ns1="http://schemas.openxmlformats.org/officeDocument/2006/relationships" ns1:id="rIdRemainderLink1"/>
@@ -1878,7 +1878,7 @@
                 <a:ea typeface="Arial"/>
                 <a:cs typeface="Arial"/>
               </a:rPr>
-              <a:t>Shivam Gupta / remainder-apex.onrender.com</a:t>
+              <a:t>Shivam Gupta / remainder-desk.web.app</a:t>
             </a:r>
           </a:p>
         </p:txBody>
@@ -1888,7 +1888,7 @@
           <p:cNvPr id="4" name="">
             <a:extLst xmlns:a="http://schemas.openxmlformats.org/drawingml/2006/main">
               <a:ext uri="{FF2B5EF4-FFF2-40B4-BE49-F238E27FC236}">
-                <a16:creationId xmlns:a16="http://schemas.microsoft.com/office/drawing/2014/main" id="{70F82C7F-2008-410F-A8AA-D7395BF22791}"/>
+                <a16:creationId xmlns:a16="http://schemas.microsoft.com/office/drawing/2014/main" id="{C5481118-994A-4048-9766-8F729BCA8D13}"/>
               </a:ext>
             </a:extLst>
           </p:cNvPr>
@@ -1943,7 +1943,7 @@
     </p:spTree>
     <p:extLst>
       <p:ext uri="{BB962C8B-B14F-4D97-AF65-F5344CB8AC3E}">
-        <p14:creationId xmlns:p14="http://schemas.microsoft.com/office/powerpoint/2010/main" val="1209391857"/>
+        <p14:creationId xmlns:p14="http://schemas.microsoft.com/office/powerpoint/2010/main" val="837206148"/>
       </p:ext>
     </p:extLst>
   </p:cSld>
@@ -1974,7 +1974,7 @@
           <p:cNvPr id="8" name="">
             <a:extLst xmlns:a="http://schemas.openxmlformats.org/drawingml/2006/main">
               <a:ext uri="{FF2B5EF4-FFF2-40B4-BE49-F238E27FC236}">
-                <a16:creationId xmlns:a16="http://schemas.microsoft.com/office/drawing/2014/main" id="{05A947D7-C50B-4CFC-95D5-3D1473C9729C}"/>
+                <a16:creationId xmlns:a16="http://schemas.microsoft.com/office/drawing/2014/main" id="{2C590C64-F2B4-4021-80FE-C34453CB2213}"/>
               </a:ext>
             </a:extLst>
           </p:cNvPr>
@@ -2031,7 +2031,7 @@
           <p:cNvPr id="2" name="">
             <a:extLst xmlns:a="http://schemas.openxmlformats.org/drawingml/2006/main">
               <a:ext uri="{FF2B5EF4-FFF2-40B4-BE49-F238E27FC236}">
-                <a16:creationId xmlns:a16="http://schemas.microsoft.com/office/drawing/2014/main" id="{81318614-DE0A-4C14-85F9-1481D78EAF6F}"/>
+                <a16:creationId xmlns:a16="http://schemas.microsoft.com/office/drawing/2014/main" id="{A123D678-26BF-4859-9540-F331EC5BC227}"/>
               </a:ext>
             </a:extLst>
           </p:cNvPr>
@@ -2088,7 +2088,7 @@
           <p:cNvPr id="3" name="">
             <a:extLst xmlns:a="http://schemas.openxmlformats.org/drawingml/2006/main">
               <a:ext uri="{FF2B5EF4-FFF2-40B4-BE49-F238E27FC236}">
-                <a16:creationId xmlns:a16="http://schemas.microsoft.com/office/drawing/2014/main" id="{1C717E1B-AB34-4486-B217-A477F719020D}"/>
+                <a16:creationId xmlns:a16="http://schemas.microsoft.com/office/drawing/2014/main" id="{5F396733-33E4-45F6-9BE4-5188C51AAC35}"/>
               </a:ext>
             </a:extLst>
           </p:cNvPr>
@@ -2168,7 +2168,7 @@
           <p:cNvPr id="4" name="">
             <a:extLst xmlns:a="http://schemas.openxmlformats.org/drawingml/2006/main">
               <a:ext uri="{FF2B5EF4-FFF2-40B4-BE49-F238E27FC236}">
-                <a16:creationId xmlns:a16="http://schemas.microsoft.com/office/drawing/2014/main" id="{4EAD0B73-11BC-47A8-B490-585C79AAF02D}"/>
+                <a16:creationId xmlns:a16="http://schemas.microsoft.com/office/drawing/2014/main" id="{4AD5A051-8A16-430E-8334-2B9A0DAF0F08}"/>
               </a:ext>
             </a:extLst>
           </p:cNvPr>
@@ -2248,7 +2248,7 @@
           <p:cNvPr id="5" name="">
             <a:extLst xmlns:a="http://schemas.openxmlformats.org/drawingml/2006/main">
               <a:ext uri="{FF2B5EF4-FFF2-40B4-BE49-F238E27FC236}">
-                <a16:creationId xmlns:a16="http://schemas.microsoft.com/office/drawing/2014/main" id="{F4022EC7-2D36-4312-B72F-C2D3E9B7AA97}"/>
+                <a16:creationId xmlns:a16="http://schemas.microsoft.com/office/drawing/2014/main" id="{52AF150C-4687-4117-A452-5777C33966AD}"/>
               </a:ext>
             </a:extLst>
           </p:cNvPr>
@@ -2305,7 +2305,7 @@
           <p:cNvPr id="6" name="">
             <a:extLst xmlns:a="http://schemas.openxmlformats.org/drawingml/2006/main">
               <a:ext uri="{FF2B5EF4-FFF2-40B4-BE49-F238E27FC236}">
-                <a16:creationId xmlns:a16="http://schemas.microsoft.com/office/drawing/2014/main" id="{679F9C4D-2E4F-4BBB-8F05-CFE3B4E38D38}"/>
+                <a16:creationId xmlns:a16="http://schemas.microsoft.com/office/drawing/2014/main" id="{D84EA4FC-80C6-4BFD-B423-66208A63C785}"/>
               </a:ext>
             </a:extLst>
           </p:cNvPr>
@@ -2362,7 +2362,7 @@
           <p:cNvPr id="7" name="">
             <a:extLst xmlns:a="http://schemas.openxmlformats.org/drawingml/2006/main">
               <a:ext uri="{FF2B5EF4-FFF2-40B4-BE49-F238E27FC236}">
-                <a16:creationId xmlns:a16="http://schemas.microsoft.com/office/drawing/2014/main" id="{40F60D2F-CA0A-42E8-A025-E1D3CE4A12A9}"/>
+                <a16:creationId xmlns:a16="http://schemas.microsoft.com/office/drawing/2014/main" id="{1A4BB272-2721-4DC5-A15B-DDB2EEC57CFA}"/>
               </a:ext>
             </a:extLst>
           </p:cNvPr>
@@ -2417,7 +2417,7 @@
     </p:spTree>
     <p:extLst>
       <p:ext uri="{BB962C8B-B14F-4D97-AF65-F5344CB8AC3E}">
-        <p14:creationId xmlns:p14="http://schemas.microsoft.com/office/powerpoint/2010/main" val="928052862"/>
+        <p14:creationId xmlns:p14="http://schemas.microsoft.com/office/powerpoint/2010/main" val="1057381220"/>
       </p:ext>
     </p:extLst>
   </p:cSld>
@@ -2448,7 +2448,7 @@
           <p:cNvPr id="9" name="">
             <a:extLst xmlns:a="http://schemas.openxmlformats.org/drawingml/2006/main">
               <a:ext uri="{FF2B5EF4-FFF2-40B4-BE49-F238E27FC236}">
-                <a16:creationId xmlns:a16="http://schemas.microsoft.com/office/drawing/2014/main" id="{E9FA9509-960D-466F-A3BC-8AA693991DAB}"/>
+                <a16:creationId xmlns:a16="http://schemas.microsoft.com/office/drawing/2014/main" id="{324FF07D-5C1E-410D-825C-02C2C5BD1523}"/>
               </a:ext>
             </a:extLst>
           </p:cNvPr>
@@ -2505,7 +2505,7 @@
           <p:cNvPr id="2" name="">
             <a:extLst xmlns:a="http://schemas.openxmlformats.org/drawingml/2006/main">
               <a:ext uri="{FF2B5EF4-FFF2-40B4-BE49-F238E27FC236}">
-                <a16:creationId xmlns:a16="http://schemas.microsoft.com/office/drawing/2014/main" id="{02EC485F-3C92-4169-BFD1-66538B859176}"/>
+                <a16:creationId xmlns:a16="http://schemas.microsoft.com/office/drawing/2014/main" id="{893457DD-170F-4A8C-AF55-EC482A1761CC}"/>
               </a:ext>
             </a:extLst>
           </p:cNvPr>
@@ -2562,7 +2562,7 @@
           <p:cNvPr id="3" name="">
             <a:extLst xmlns:a="http://schemas.openxmlformats.org/drawingml/2006/main">
               <a:ext uri="{FF2B5EF4-FFF2-40B4-BE49-F238E27FC236}">
-                <a16:creationId xmlns:a16="http://schemas.microsoft.com/office/drawing/2014/main" id="{7A6435E8-5AB2-4D38-B5EC-34D4D1E66D9C}"/>
+                <a16:creationId xmlns:a16="http://schemas.microsoft.com/office/drawing/2014/main" id="{AAED7AB2-A023-4F7E-9A9B-7E74CD0C68DF}"/>
               </a:ext>
             </a:extLst>
           </p:cNvPr>
@@ -2626,7 +2626,7 @@
         </p:xfrm>
         <a:graphic xmlns:a="http://schemas.openxmlformats.org/drawingml/2006/main">
           <a:graphicData uri="http://schemas.openxmlformats.org/drawingml/2006/chart">
-            <c:chart xmlns:r="http://schemas.openxmlformats.org/officeDocument/2006/relationships" xmlns:c="http://schemas.openxmlformats.org/drawingml/2006/chart" r:id="R5de3f4773a0b4e0d"/>
+            <c:chart xmlns:r="http://schemas.openxmlformats.org/officeDocument/2006/relationships" xmlns:c="http://schemas.openxmlformats.org/drawingml/2006/chart" r:id="R87a73e4338e74647"/>
           </a:graphicData>
         </a:graphic>
       </p:graphicFrame>
@@ -2635,7 +2635,7 @@
           <p:cNvPr id="5" name="">
             <a:extLst xmlns:a="http://schemas.openxmlformats.org/drawingml/2006/main">
               <a:ext uri="{FF2B5EF4-FFF2-40B4-BE49-F238E27FC236}">
-                <a16:creationId xmlns:a16="http://schemas.microsoft.com/office/drawing/2014/main" id="{898DF6C1-A37A-4084-903B-2EB72C8FCE7B}"/>
+                <a16:creationId xmlns:a16="http://schemas.microsoft.com/office/drawing/2014/main" id="{AA76B98B-B6AC-4705-B571-F501A7DB271D}"/>
               </a:ext>
             </a:extLst>
           </p:cNvPr>
@@ -2692,7 +2692,7 @@
           <p:cNvPr id="6" name="">
             <a:extLst xmlns:a="http://schemas.openxmlformats.org/drawingml/2006/main">
               <a:ext uri="{FF2B5EF4-FFF2-40B4-BE49-F238E27FC236}">
-                <a16:creationId xmlns:a16="http://schemas.microsoft.com/office/drawing/2014/main" id="{AC0A9D3F-F9B6-4E85-84ED-E18EE88D4FC8}"/>
+                <a16:creationId xmlns:a16="http://schemas.microsoft.com/office/drawing/2014/main" id="{3C244FD7-2C2D-4809-A906-43B2E41C3A4A}"/>
               </a:ext>
             </a:extLst>
           </p:cNvPr>
@@ -2749,7 +2749,7 @@
           <p:cNvPr id="7" name="">
             <a:extLst xmlns:a="http://schemas.openxmlformats.org/drawingml/2006/main">
               <a:ext uri="{FF2B5EF4-FFF2-40B4-BE49-F238E27FC236}">
-                <a16:creationId xmlns:a16="http://schemas.microsoft.com/office/drawing/2014/main" id="{4078A1FB-4D5B-4D88-B6E6-288057F384DE}"/>
+                <a16:creationId xmlns:a16="http://schemas.microsoft.com/office/drawing/2014/main" id="{782C98B6-65FC-49AE-A77F-F157B4697422}"/>
               </a:ext>
             </a:extLst>
           </p:cNvPr>
@@ -2806,7 +2806,7 @@
           <p:cNvPr id="8" name="">
             <a:extLst xmlns:a="http://schemas.openxmlformats.org/drawingml/2006/main">
               <a:ext uri="{FF2B5EF4-FFF2-40B4-BE49-F238E27FC236}">
-                <a16:creationId xmlns:a16="http://schemas.microsoft.com/office/drawing/2014/main" id="{71A1C700-B618-4402-BB61-2AA39F758AF9}"/>
+                <a16:creationId xmlns:a16="http://schemas.microsoft.com/office/drawing/2014/main" id="{40506FDD-FF49-40D8-9E2B-0D8CF0E6F4DA}"/>
               </a:ext>
             </a:extLst>
           </p:cNvPr>
@@ -2861,7 +2861,7 @@
     </p:spTree>
     <p:extLst>
       <p:ext uri="{BB962C8B-B14F-4D97-AF65-F5344CB8AC3E}">
-        <p14:creationId xmlns:p14="http://schemas.microsoft.com/office/powerpoint/2010/main" val="1267956841"/>
+        <p14:creationId xmlns:p14="http://schemas.microsoft.com/office/powerpoint/2010/main" val="821472891"/>
       </p:ext>
     </p:extLst>
   </p:cSld>
@@ -2892,7 +2892,7 @@
           <p:cNvPr id="10" name="">
             <a:extLst xmlns:a="http://schemas.openxmlformats.org/drawingml/2006/main">
               <a:ext uri="{FF2B5EF4-FFF2-40B4-BE49-F238E27FC236}">
-                <a16:creationId xmlns:a16="http://schemas.microsoft.com/office/drawing/2014/main" id="{D9A0F9E4-FDB4-432D-BF1F-1978A123BB0C}"/>
+                <a16:creationId xmlns:a16="http://schemas.microsoft.com/office/drawing/2014/main" id="{135182B4-BD47-4162-8E74-0291F2F32A33}"/>
               </a:ext>
             </a:extLst>
           </p:cNvPr>
@@ -2949,7 +2949,7 @@
           <p:cNvPr id="2" name="">
             <a:extLst xmlns:a="http://schemas.openxmlformats.org/drawingml/2006/main">
               <a:ext uri="{FF2B5EF4-FFF2-40B4-BE49-F238E27FC236}">
-                <a16:creationId xmlns:a16="http://schemas.microsoft.com/office/drawing/2014/main" id="{C379D958-94B4-4951-B6F7-16DF3BE4BD95}"/>
+                <a16:creationId xmlns:a16="http://schemas.microsoft.com/office/drawing/2014/main" id="{3F140D26-7D61-4A4D-A812-4F08F8684F29}"/>
               </a:ext>
             </a:extLst>
           </p:cNvPr>
@@ -3006,7 +3006,7 @@
           <p:cNvPr id="3" name="">
             <a:extLst xmlns:a="http://schemas.openxmlformats.org/drawingml/2006/main">
               <a:ext uri="{FF2B5EF4-FFF2-40B4-BE49-F238E27FC236}">
-                <a16:creationId xmlns:a16="http://schemas.microsoft.com/office/drawing/2014/main" id="{3E974435-953D-4198-A7BD-0DC49206066F}"/>
+                <a16:creationId xmlns:a16="http://schemas.microsoft.com/office/drawing/2014/main" id="{EEB24636-D73F-485C-85D6-FCC688F85E0A}"/>
               </a:ext>
             </a:extLst>
           </p:cNvPr>
@@ -3053,7 +3053,7 @@
                 <a:ea typeface="Arial"/>
                 <a:cs typeface="Arial"/>
               </a:rPr>
-              <a:t>Gemini passed two live synthetic cases.</a:t>
+              <a:t>OpenAI gpt-5.4-mini proposes line items.</a:t>
             </a:r>
           </a:p>
           <a:p xmlns:a="http://schemas.openxmlformats.org/drawingml/2006/main">
@@ -3076,7 +3076,7 @@
                 <a:ea typeface="Arial"/>
                 <a:cs typeface="Arial"/>
               </a:rPr>
-              <a:t>AI proposes matching line items.</a:t>
+              <a:t>The film shows two real AI requests.</a:t>
             </a:r>
           </a:p>
         </p:txBody>
@@ -3086,7 +3086,7 @@
           <p:cNvPr id="4" name="">
             <a:extLst xmlns:a="http://schemas.openxmlformats.org/drawingml/2006/main">
               <a:ext uri="{FF2B5EF4-FFF2-40B4-BE49-F238E27FC236}">
-                <a16:creationId xmlns:a16="http://schemas.microsoft.com/office/drawing/2014/main" id="{E59FCF57-B2B7-404A-895F-EA5E65CDE7FF}"/>
+                <a16:creationId xmlns:a16="http://schemas.microsoft.com/office/drawing/2014/main" id="{E57C9731-FA73-40FC-8D59-15C77B5029A9}"/>
               </a:ext>
             </a:extLst>
           </p:cNvPr>
@@ -3143,7 +3143,7 @@
           <p:cNvPr id="5" name="">
             <a:extLst xmlns:a="http://schemas.openxmlformats.org/drawingml/2006/main">
               <a:ext uri="{FF2B5EF4-FFF2-40B4-BE49-F238E27FC236}">
-                <a16:creationId xmlns:a16="http://schemas.microsoft.com/office/drawing/2014/main" id="{CD3A900B-B586-44EE-B217-17B3E3BFC92E}"/>
+                <a16:creationId xmlns:a16="http://schemas.microsoft.com/office/drawing/2014/main" id="{B8E809B1-E865-4B4A-9B99-84C1DDF4955F}"/>
               </a:ext>
             </a:extLst>
           </p:cNvPr>
@@ -3213,7 +3213,7 @@
                 <a:ea typeface="Arial"/>
                 <a:cs typeface="Arial"/>
               </a:rPr>
-              <a:t>Signed Evorozen aliases aid later cases.</a:t>
+              <a:t>Optional signed Evorozen aliases aid recall.</a:t>
             </a:r>
           </a:p>
         </p:txBody>
@@ -3223,7 +3223,7 @@
           <p:cNvPr id="6" name="">
             <a:extLst xmlns:a="http://schemas.openxmlformats.org/drawingml/2006/main">
               <a:ext uri="{FF2B5EF4-FFF2-40B4-BE49-F238E27FC236}">
-                <a16:creationId xmlns:a16="http://schemas.microsoft.com/office/drawing/2014/main" id="{CC35C615-2B44-4B9A-A800-90829E22E6FD}"/>
+                <a16:creationId xmlns:a16="http://schemas.microsoft.com/office/drawing/2014/main" id="{23BF618B-4045-4AC7-96E5-0F669184A0E7}"/>
               </a:ext>
             </a:extLst>
           </p:cNvPr>
@@ -3280,7 +3280,7 @@
           <p:cNvPr id="7" name="">
             <a:extLst xmlns:a="http://schemas.openxmlformats.org/drawingml/2006/main">
               <a:ext uri="{FF2B5EF4-FFF2-40B4-BE49-F238E27FC236}">
-                <a16:creationId xmlns:a16="http://schemas.microsoft.com/office/drawing/2014/main" id="{F7B0C0CB-C42B-4D5B-B061-F73D2080DB61}"/>
+                <a16:creationId xmlns:a16="http://schemas.microsoft.com/office/drawing/2014/main" id="{643F59B0-071D-4F2D-968E-AB632ECFC104}"/>
               </a:ext>
             </a:extLst>
           </p:cNvPr>
@@ -3360,7 +3360,7 @@
           <p:cNvPr id="8" name="">
             <a:extLst xmlns:a="http://schemas.openxmlformats.org/drawingml/2006/main">
               <a:ext uri="{FF2B5EF4-FFF2-40B4-BE49-F238E27FC236}">
-                <a16:creationId xmlns:a16="http://schemas.microsoft.com/office/drawing/2014/main" id="{706CFA19-E8E1-4C24-8ACA-1D60A7A3CFB2}"/>
+                <a16:creationId xmlns:a16="http://schemas.microsoft.com/office/drawing/2014/main" id="{377739A2-6EB8-4A60-98DA-368CF4221EB5}"/>
               </a:ext>
             </a:extLst>
           </p:cNvPr>
@@ -3407,7 +3407,7 @@
                 <a:ea typeface="Arial"/>
                 <a:cs typeface="Arial"/>
               </a:rPr>
-              <a:t>Gemini extraction + signed Evorozen memory verified. Sample footage uses replay.</a:t>
+              <a:t>Six fixed synthetic model cases passed. Optional Evorozen memory verified separately.</a:t>
             </a:r>
           </a:p>
         </p:txBody>
@@ -3417,7 +3417,7 @@
           <p:cNvPr id="9" name="">
             <a:extLst xmlns:a="http://schemas.openxmlformats.org/drawingml/2006/main">
               <a:ext uri="{FF2B5EF4-FFF2-40B4-BE49-F238E27FC236}">
-                <a16:creationId xmlns:a16="http://schemas.microsoft.com/office/drawing/2014/main" id="{D952B965-DD48-44B6-A823-A5A6DD8E7581}"/>
+                <a16:creationId xmlns:a16="http://schemas.microsoft.com/office/drawing/2014/main" id="{9009A49A-4ECD-4888-8A2B-66B88CC61746}"/>
               </a:ext>
             </a:extLst>
           </p:cNvPr>
@@ -3472,7 +3472,7 @@
     </p:spTree>
     <p:extLst>
       <p:ext uri="{BB962C8B-B14F-4D97-AF65-F5344CB8AC3E}">
-        <p14:creationId xmlns:p14="http://schemas.microsoft.com/office/powerpoint/2010/main" val="1563049283"/>
+        <p14:creationId xmlns:p14="http://schemas.microsoft.com/office/powerpoint/2010/main" val="241637635"/>
       </p:ext>
     </p:extLst>
   </p:cSld>
@@ -3503,7 +3503,7 @@
           <p:cNvPr id="7" name="">
             <a:extLst xmlns:a="http://schemas.openxmlformats.org/drawingml/2006/main">
               <a:ext uri="{FF2B5EF4-FFF2-40B4-BE49-F238E27FC236}">
-                <a16:creationId xmlns:a16="http://schemas.microsoft.com/office/drawing/2014/main" id="{C79A5D9E-F9B3-4D97-8E15-B690962070AD}"/>
+                <a16:creationId xmlns:a16="http://schemas.microsoft.com/office/drawing/2014/main" id="{971FB76D-F50C-43C1-A264-8BD3C8D7BAC4}"/>
               </a:ext>
             </a:extLst>
           </p:cNvPr>
@@ -3560,7 +3560,7 @@
           <p:cNvPr id="2" name="">
             <a:extLst xmlns:a="http://schemas.openxmlformats.org/drawingml/2006/main">
               <a:ext uri="{FF2B5EF4-FFF2-40B4-BE49-F238E27FC236}">
-                <a16:creationId xmlns:a16="http://schemas.microsoft.com/office/drawing/2014/main" id="{CA0D2088-2476-4B42-BCFA-273B49E27EE0}"/>
+                <a16:creationId xmlns:a16="http://schemas.microsoft.com/office/drawing/2014/main" id="{59ABF471-C4B3-4132-B95E-185C4E2F8D11}"/>
               </a:ext>
             </a:extLst>
           </p:cNvPr>
@@ -3640,7 +3640,7 @@
           <p:cNvPr id="3" name="">
             <a:extLst xmlns:a="http://schemas.openxmlformats.org/drawingml/2006/main">
               <a:ext uri="{FF2B5EF4-FFF2-40B4-BE49-F238E27FC236}">
-                <a16:creationId xmlns:a16="http://schemas.microsoft.com/office/drawing/2014/main" id="{303B84DA-3D2C-4E14-A428-B13A9C220C1E}"/>
+                <a16:creationId xmlns:a16="http://schemas.microsoft.com/office/drawing/2014/main" id="{86F77A3C-E2DC-41CE-A55B-FABE61C59CE2}"/>
               </a:ext>
             </a:extLst>
           </p:cNvPr>
@@ -3743,7 +3743,7 @@
           <p:cNvPr id="4" name="">
             <a:extLst xmlns:a="http://schemas.openxmlformats.org/drawingml/2006/main">
               <a:ext uri="{FF2B5EF4-FFF2-40B4-BE49-F238E27FC236}">
-                <a16:creationId xmlns:a16="http://schemas.microsoft.com/office/drawing/2014/main" id="{F8AF7571-FB9E-4F40-AA4C-56E7F020C24B}"/>
+                <a16:creationId xmlns:a16="http://schemas.microsoft.com/office/drawing/2014/main" id="{4ABA52AF-FD60-4675-8C7E-665E580DA223}"/>
               </a:ext>
             </a:extLst>
           </p:cNvPr>
@@ -3846,7 +3846,7 @@
           <p:cNvPr id="5" name="">
             <a:extLst xmlns:a="http://schemas.openxmlformats.org/drawingml/2006/main">
               <a:ext uri="{FF2B5EF4-FFF2-40B4-BE49-F238E27FC236}">
-                <a16:creationId xmlns:a16="http://schemas.microsoft.com/office/drawing/2014/main" id="{D0C07F12-3B1B-48A2-A876-A31347B1213C}"/>
+                <a16:creationId xmlns:a16="http://schemas.microsoft.com/office/drawing/2014/main" id="{5B16744C-A1DC-4C40-843A-8C84262CB328}"/>
               </a:ext>
             </a:extLst>
           </p:cNvPr>
@@ -3903,7 +3903,7 @@
           <p:cNvPr id="6" name="">
             <a:extLst xmlns:a="http://schemas.openxmlformats.org/drawingml/2006/main">
               <a:ext uri="{FF2B5EF4-FFF2-40B4-BE49-F238E27FC236}">
-                <a16:creationId xmlns:a16="http://schemas.microsoft.com/office/drawing/2014/main" id="{71829E3F-A0E4-41B0-9A5B-A934EE389E25}"/>
+                <a16:creationId xmlns:a16="http://schemas.microsoft.com/office/drawing/2014/main" id="{2EE98926-11A9-40B0-A815-279F506B3FF2}"/>
               </a:ext>
             </a:extLst>
           </p:cNvPr>
@@ -3958,7 +3958,7 @@
     </p:spTree>
     <p:extLst>
       <p:ext uri="{BB962C8B-B14F-4D97-AF65-F5344CB8AC3E}">
-        <p14:creationId xmlns:p14="http://schemas.microsoft.com/office/powerpoint/2010/main" val="1991857087"/>
+        <p14:creationId xmlns:p14="http://schemas.microsoft.com/office/powerpoint/2010/main" val="1000840969"/>
       </p:ext>
     </p:extLst>
   </p:cSld>
@@ -3989,7 +3989,7 @@
           <p:cNvPr id="8" name="">
             <a:extLst xmlns:a="http://schemas.openxmlformats.org/drawingml/2006/main">
               <a:ext uri="{FF2B5EF4-FFF2-40B4-BE49-F238E27FC236}">
-                <a16:creationId xmlns:a16="http://schemas.microsoft.com/office/drawing/2014/main" id="{11775A4B-3052-4FCC-8C7C-6D86E5F8A59F}"/>
+                <a16:creationId xmlns:a16="http://schemas.microsoft.com/office/drawing/2014/main" id="{03912351-BB8C-4006-9510-5E62106FA3D3}"/>
               </a:ext>
             </a:extLst>
           </p:cNvPr>
@@ -4046,7 +4046,7 @@
           <p:cNvPr id="2" name="">
             <a:extLst xmlns:a="http://schemas.openxmlformats.org/drawingml/2006/main">
               <a:ext uri="{FF2B5EF4-FFF2-40B4-BE49-F238E27FC236}">
-                <a16:creationId xmlns:a16="http://schemas.microsoft.com/office/drawing/2014/main" id="{8FD59A5A-7658-421C-B6AF-8FB6424080D2}"/>
+                <a16:creationId xmlns:a16="http://schemas.microsoft.com/office/drawing/2014/main" id="{99B58868-918D-4185-8855-D1D542453D43}"/>
               </a:ext>
             </a:extLst>
           </p:cNvPr>
@@ -4103,7 +4103,7 @@
           <p:cNvPr id="3" name="">
             <a:extLst xmlns:a="http://schemas.openxmlformats.org/drawingml/2006/main">
               <a:ext uri="{FF2B5EF4-FFF2-40B4-BE49-F238E27FC236}">
-                <a16:creationId xmlns:a16="http://schemas.microsoft.com/office/drawing/2014/main" id="{39AF666A-88D5-4F2C-8B1C-52256D4412F7}"/>
+                <a16:creationId xmlns:a16="http://schemas.microsoft.com/office/drawing/2014/main" id="{77F672AE-A122-47DF-B85A-2F6FEA5DAEA6}"/>
               </a:ext>
             </a:extLst>
           </p:cNvPr>
@@ -4160,7 +4160,7 @@
           <p:cNvPr id="4" name="">
             <a:extLst xmlns:a="http://schemas.openxmlformats.org/drawingml/2006/main">
               <a:ext uri="{FF2B5EF4-FFF2-40B4-BE49-F238E27FC236}">
-                <a16:creationId xmlns:a16="http://schemas.microsoft.com/office/drawing/2014/main" id="{AD60E79F-24D7-49AA-8B60-90CE3B7417AD}"/>
+                <a16:creationId xmlns:a16="http://schemas.microsoft.com/office/drawing/2014/main" id="{357F0E47-D9CE-4153-B7E3-6B1DD2873465}"/>
               </a:ext>
             </a:extLst>
           </p:cNvPr>
@@ -4240,7 +4240,7 @@
           <p:cNvPr id="5" name="">
             <a:extLst xmlns:a="http://schemas.openxmlformats.org/drawingml/2006/main">
               <a:ext uri="{FF2B5EF4-FFF2-40B4-BE49-F238E27FC236}">
-                <a16:creationId xmlns:a16="http://schemas.microsoft.com/office/drawing/2014/main" id="{287C8AC4-6037-4EA9-B6AF-EF1EB53073D7}"/>
+                <a16:creationId xmlns:a16="http://schemas.microsoft.com/office/drawing/2014/main" id="{408BD99C-4150-4F27-AA05-AC25A08BDDFA}"/>
               </a:ext>
             </a:extLst>
           </p:cNvPr>
@@ -4343,7 +4343,7 @@
           <p:cNvPr id="6" name="">
             <a:extLst xmlns:a="http://schemas.openxmlformats.org/drawingml/2006/main">
               <a:ext uri="{FF2B5EF4-FFF2-40B4-BE49-F238E27FC236}">
-                <a16:creationId xmlns:a16="http://schemas.microsoft.com/office/drawing/2014/main" id="{05C5934B-87D8-4533-9146-69C544026029}"/>
+                <a16:creationId xmlns:a16="http://schemas.microsoft.com/office/drawing/2014/main" id="{6C75B3B3-B896-4E6E-A898-F1451C305E55}"/>
               </a:ext>
             </a:extLst>
           </p:cNvPr>
@@ -4390,7 +4390,7 @@
                 <a:ea typeface="Arial"/>
                 <a:cs typeface="Arial"/>
               </a:rPr>
-              <a:t>Pricing hypothesis. Evorozen advertises the first 50 calls free, a finite launch allowance.</a:t>
+              <a:t>Pricing and allowance are hypotheses. No customers, revenue, or paid commitments claimed.</a:t>
             </a:r>
           </a:p>
         </p:txBody>
@@ -4400,7 +4400,7 @@
           <p:cNvPr id="7" name="">
             <a:extLst xmlns:a="http://schemas.openxmlformats.org/drawingml/2006/main">
               <a:ext uri="{FF2B5EF4-FFF2-40B4-BE49-F238E27FC236}">
-                <a16:creationId xmlns:a16="http://schemas.microsoft.com/office/drawing/2014/main" id="{44B74206-06CB-4E76-9A7E-5750088B0A67}"/>
+                <a16:creationId xmlns:a16="http://schemas.microsoft.com/office/drawing/2014/main" id="{848A9EDB-12E3-4910-9436-1FB15BC70AA8}"/>
               </a:ext>
             </a:extLst>
           </p:cNvPr>
@@ -4455,7 +4455,7 @@
     </p:spTree>
     <p:extLst>
       <p:ext uri="{BB962C8B-B14F-4D97-AF65-F5344CB8AC3E}">
-        <p14:creationId xmlns:p14="http://schemas.microsoft.com/office/powerpoint/2010/main" val="121508953"/>
+        <p14:creationId xmlns:p14="http://schemas.microsoft.com/office/powerpoint/2010/main" val="574278191"/>
       </p:ext>
     </p:extLst>
   </p:cSld>
@@ -4486,7 +4486,7 @@
           <p:cNvPr id="7" name="">
             <a:extLst xmlns:a="http://schemas.openxmlformats.org/drawingml/2006/main">
               <a:ext uri="{FF2B5EF4-FFF2-40B4-BE49-F238E27FC236}">
-                <a16:creationId xmlns:a16="http://schemas.microsoft.com/office/drawing/2014/main" id="{170E695D-732D-436F-9583-D27AD9F5C17C}"/>
+                <a16:creationId xmlns:a16="http://schemas.microsoft.com/office/drawing/2014/main" id="{C646A3F6-B169-49C9-87D9-41FD11C5EED6}"/>
               </a:ext>
             </a:extLst>
           </p:cNvPr>
@@ -4566,7 +4566,7 @@
           <p:cNvPr id="2" name="">
             <a:extLst xmlns:a="http://schemas.openxmlformats.org/drawingml/2006/main">
               <a:ext uri="{FF2B5EF4-FFF2-40B4-BE49-F238E27FC236}">
-                <a16:creationId xmlns:a16="http://schemas.microsoft.com/office/drawing/2014/main" id="{83F2DE22-BADF-43DB-A51B-BCFDDCF7FE85}"/>
+                <a16:creationId xmlns:a16="http://schemas.microsoft.com/office/drawing/2014/main" id="{D0D36188-D3A0-40A4-AAB9-A730D9F7FF65}"/>
               </a:ext>
             </a:extLst>
           </p:cNvPr>
@@ -4623,7 +4623,7 @@
           <p:cNvPr id="3" name="">
             <a:extLst xmlns:a="http://schemas.openxmlformats.org/drawingml/2006/main">
               <a:ext uri="{FF2B5EF4-FFF2-40B4-BE49-F238E27FC236}">
-                <a16:creationId xmlns:a16="http://schemas.microsoft.com/office/drawing/2014/main" id="{E54916AC-1C8D-4476-B9F9-E73768B05386}"/>
+                <a16:creationId xmlns:a16="http://schemas.microsoft.com/office/drawing/2014/main" id="{36CBFFE8-F45C-4282-BE90-4E7A23CB9237}"/>
               </a:ext>
             </a:extLst>
           </p:cNvPr>
@@ -4726,7 +4726,7 @@
           <p:cNvPr id="4" name="">
             <a:extLst xmlns:a="http://schemas.openxmlformats.org/drawingml/2006/main">
               <a:ext uri="{FF2B5EF4-FFF2-40B4-BE49-F238E27FC236}">
-                <a16:creationId xmlns:a16="http://schemas.microsoft.com/office/drawing/2014/main" id="{E80DF654-BDD0-45A4-8BEE-C1E0DE5367A2}"/>
+                <a16:creationId xmlns:a16="http://schemas.microsoft.com/office/drawing/2014/main" id="{083FCDF4-E976-4CC6-97D5-1DF806D6BA9D}"/>
               </a:ext>
             </a:extLst>
             <ns0:hlinkClick xmlns:ns0="http://schemas.openxmlformats.org/drawingml/2006/main" xmlns:ns1="http://schemas.openxmlformats.org/officeDocument/2006/relationships" ns1:id="rIdRemainderLink2"/>
@@ -4774,7 +4774,7 @@
                 <a:ea typeface="Arial"/>
                 <a:cs typeface="Arial"/>
               </a:rPr>
-              <a:t>remainder-apex.onrender.com →</a:t>
+              <a:t>remainder-desk.web.app →</a:t>
             </a:r>
           </a:p>
         </p:txBody>
@@ -4784,7 +4784,7 @@
           <p:cNvPr id="5" name="">
             <a:extLst xmlns:a="http://schemas.openxmlformats.org/drawingml/2006/main">
               <a:ext uri="{FF2B5EF4-FFF2-40B4-BE49-F238E27FC236}">
-                <a16:creationId xmlns:a16="http://schemas.microsoft.com/office/drawing/2014/main" id="{92019A81-EF1E-4E1C-A51F-90A08D9D7A28}"/>
+                <a16:creationId xmlns:a16="http://schemas.microsoft.com/office/drawing/2014/main" id="{5CB3F50E-5D40-4627-8B46-68E4F9A43447}"/>
               </a:ext>
             </a:extLst>
             <ns2:hlinkClick xmlns:ns2="http://schemas.openxmlformats.org/drawingml/2006/main" xmlns:ns3="http://schemas.openxmlformats.org/officeDocument/2006/relationships" ns3:id="rIdRemainderLink3"/>
@@ -4842,7 +4842,7 @@
           <p:cNvPr id="6" name="">
             <a:extLst xmlns:a="http://schemas.openxmlformats.org/drawingml/2006/main">
               <a:ext uri="{FF2B5EF4-FFF2-40B4-BE49-F238E27FC236}">
-                <a16:creationId xmlns:a16="http://schemas.microsoft.com/office/drawing/2014/main" id="{25AB16EA-1205-4F2C-A13F-C578766939FF}"/>
+                <a16:creationId xmlns:a16="http://schemas.microsoft.com/office/drawing/2014/main" id="{6FA70CAE-1E5F-4530-8A85-405D3A6E534F}"/>
               </a:ext>
             </a:extLst>
           </p:cNvPr>
@@ -4897,7 +4897,7 @@
     </p:spTree>
     <p:extLst>
       <p:ext uri="{BB962C8B-B14F-4D97-AF65-F5344CB8AC3E}">
-        <p14:creationId xmlns:p14="http://schemas.microsoft.com/office/powerpoint/2010/main" val="727334325"/>
+        <p14:creationId xmlns:p14="http://schemas.microsoft.com/office/powerpoint/2010/main" val="1190533566"/>
       </p:ext>
     </p:extLst>
   </p:cSld>

</xml_diff>